<commit_message>
Cập nhật slide: Thêm kết quả kiểm thử test API
</commit_message>
<xml_diff>
--- a/docs/slide.pptx
+++ b/docs/slide.pptx
@@ -5,7 +5,7 @@
     <p:sldMasterId id="2147483648" r:id="rId1"/>
   </p:sldMasterIdLst>
   <p:notesMasterIdLst>
-    <p:notesMasterId r:id="rId19"/>
+    <p:notesMasterId r:id="rId20"/>
   </p:notesMasterIdLst>
   <p:sldIdLst>
     <p:sldId id="256" r:id="rId2"/>
@@ -23,8 +23,9 @@
     <p:sldId id="268" r:id="rId14"/>
     <p:sldId id="269" r:id="rId15"/>
     <p:sldId id="270" r:id="rId16"/>
-    <p:sldId id="271" r:id="rId17"/>
-    <p:sldId id="272" r:id="rId18"/>
+    <p:sldId id="273" r:id="rId17"/>
+    <p:sldId id="271" r:id="rId18"/>
+    <p:sldId id="272" r:id="rId19"/>
   </p:sldIdLst>
   <p:sldSz cx="12192000" cy="6858000"/>
   <p:notesSz cx="6858000" cy="12192000"/>
@@ -906,7 +907,7 @@
           <a:p>
             <a:fld id="{F7021451-1387-4CA6-816F-3879F97B5CBC}" type="slidenum">
               <a:rPr lang="en-US"/>
-              <a:t>16</a:t>
+              <a:t>17</a:t>
             </a:fld>
             <a:endParaRPr lang="en-US"/>
           </a:p>
@@ -990,7 +991,7 @@
           <a:p>
             <a:fld id="{F7021451-1387-4CA6-816F-3879F97B5CBC}" type="slidenum">
               <a:rPr lang="en-US"/>
-              <a:t>17</a:t>
+              <a:t>18</a:t>
             </a:fld>
             <a:endParaRPr lang="en-US"/>
           </a:p>
@@ -7643,6 +7644,66 @@
 
 <file path=ppt/slides/slide16.xml><?xml version="1.0" encoding="utf-8"?>
 <p:sld xmlns:a="http://schemas.openxmlformats.org/drawingml/2006/main" xmlns:r="http://schemas.openxmlformats.org/officeDocument/2006/relationships" xmlns:p="http://schemas.openxmlformats.org/presentationml/2006/main">
+  <p:cSld>
+    <p:spTree>
+      <p:nvGrpSpPr>
+        <p:cNvPr id="1" name=""/>
+        <p:cNvGrpSpPr/>
+        <p:nvPr/>
+      </p:nvGrpSpPr>
+      <p:grpSpPr>
+        <a:xfrm>
+          <a:off x="0" y="0"/>
+          <a:ext cx="0" cy="0"/>
+          <a:chOff x="0" y="0"/>
+          <a:chExt cx="0" cy="0"/>
+        </a:xfrm>
+      </p:grpSpPr>
+      <p:pic>
+        <p:nvPicPr>
+          <p:cNvPr id="3" name="Picture 2">
+            <a:extLst>
+              <a:ext uri="{FF2B5EF4-FFF2-40B4-BE49-F238E27FC236}">
+                <a16:creationId xmlns:a16="http://schemas.microsoft.com/office/drawing/2014/main" id="{3D8F7E30-E014-47A3-91F8-69150E24895C}"/>
+              </a:ext>
+            </a:extLst>
+          </p:cNvPr>
+          <p:cNvPicPr>
+            <a:picLocks noChangeAspect="1"/>
+          </p:cNvPicPr>
+          <p:nvPr/>
+        </p:nvPicPr>
+        <p:blipFill>
+          <a:blip r:embed="rId2"/>
+          <a:stretch>
+            <a:fillRect/>
+          </a:stretch>
+        </p:blipFill>
+        <p:spPr>
+          <a:xfrm>
+            <a:off x="-1" y="0"/>
+            <a:ext cx="12296025" cy="6929718"/>
+          </a:xfrm>
+          <a:prstGeom prst="rect">
+            <a:avLst/>
+          </a:prstGeom>
+        </p:spPr>
+      </p:pic>
+    </p:spTree>
+    <p:extLst>
+      <p:ext uri="{BB962C8B-B14F-4D97-AF65-F5344CB8AC3E}">
+        <p14:creationId xmlns:p14="http://schemas.microsoft.com/office/powerpoint/2010/main" val="1890813773"/>
+      </p:ext>
+    </p:extLst>
+  </p:cSld>
+  <p:clrMapOvr>
+    <a:masterClrMapping/>
+  </p:clrMapOvr>
+</p:sld>
+</file>
+
+<file path=ppt/slides/slide17.xml><?xml version="1.0" encoding="utf-8"?>
+<p:sld xmlns:a="http://schemas.openxmlformats.org/drawingml/2006/main" xmlns:r="http://schemas.openxmlformats.org/officeDocument/2006/relationships" xmlns:p="http://schemas.openxmlformats.org/presentationml/2006/main">
   <p:cSld name="Slide 16">
     <p:spTree>
       <p:nvGrpSpPr>
@@ -8651,7 +8712,7 @@
 </p:sld>
 </file>
 
-<file path=ppt/slides/slide17.xml><?xml version="1.0" encoding="utf-8"?>
+<file path=ppt/slides/slide18.xml><?xml version="1.0" encoding="utf-8"?>
 <p:sld xmlns:a="http://schemas.openxmlformats.org/drawingml/2006/main" xmlns:r="http://schemas.openxmlformats.org/officeDocument/2006/relationships" xmlns:p="http://schemas.openxmlformats.org/presentationml/2006/main">
   <p:cSld name="Slide 17">
     <p:spTree>

</xml_diff>